<commit_message>
Review-II deck: present the checklist items on the template design
Re-title and re-content every slide to the Review-II deliverables (not the
template's Review-1 fields), keeping the department template's branding:
Title(+supervisor), Outline, Research Paper Implementation, Architecture Diagram
(embedded), GitHub Code Availability, Code Execution & Results (populated table),
Contributions, Enhancements/Next work (+10-page repro doc), References, Thank you.
Reordered to the checklist sequence; 10 slides; validated.

Co-Authored-By: Claude Opus 4.8 <noreply@anthropic.com>
</commit_message>
<xml_diff>
--- a/docs/reviews/Review2_QueryGenie.pptx
+++ b/docs/reviews/Review2_QueryGenie.pptx
@@ -8,9 +8,9 @@
     <p:sldId id="264" r:id="rId2"/>
     <p:sldId id="265" r:id="rId3"/>
     <p:sldId id="270" r:id="rId4"/>
+    <p:sldId id="268" r:id="rId8"/>
+    <p:sldId id="267" r:id="rId7"/>
     <p:sldId id="266" r:id="rId5"/>
-    <p:sldId id="267" r:id="rId7"/>
-    <p:sldId id="268" r:id="rId8"/>
     <p:sldId id="272" r:id="rId9"/>
     <p:sldId id="271" r:id="rId10"/>
     <p:sldId id="273" r:id="rId11"/>
@@ -3635,7 +3635,7 @@
                   </a:schemeClr>
                 </a:solidFill>
               </a:rPr>
-              <a:t>Supervisor : M Parameswar</a:t>
+              <a:t>Project Supervisor : M Parameswar</a:t>
             </a:r>
             <a:endParaRPr lang="en-US" dirty="0"/>
           </a:p>
@@ -3726,7 +3726,7 @@
         </p:nvSpPr>
         <p:spPr/>
         <p:txBody>
-          <a:bodyPr/>
+          <a:bodyPr wrap="square"/>
           <a:lstStyle/>
           <a:p>
             <a:r>
@@ -3749,13 +3749,13 @@
           <a:p>
             <a:r>
               <a:rPr lang="en-US" dirty="0"/>
-              <a:t>Dibia, V. (2023). LIDA: Automatic Generation of Grammar-Agnostic Visualizations and Infographics using LLMs. ACL. arXiv:2303.02927</a:t>
+              <a:t>Dibia, V. (2023). LIDA: Automatic Generation of Grammar-Agnostic Visualizations using LLMs. ACL. arXiv:2303.02927</a:t>
             </a:r>
           </a:p>
           <a:p>
             <a:r>
               <a:rPr lang="en-US" dirty="0"/>
-              <a:t>Yu, T., et al. (2018). Spider: A Large-Scale Human-Labeled Dataset for Complex and Cross-Domain Semantic Parsing and Text-to-SQL. EMNLP. arXiv:1809.08887</a:t>
+              <a:t>Yu, T., et al. (2018). Spider: A Large-Scale Dataset for Complex and Cross-Domain Text-to-SQL. EMNLP. arXiv:1809.08887</a:t>
             </a:r>
           </a:p>
           <a:p>
@@ -4526,48 +4526,48 @@
         </p:nvSpPr>
         <p:spPr/>
         <p:txBody>
-          <a:bodyPr/>
+          <a:bodyPr wrap="square"/>
           <a:lstStyle/>
           <a:p>
             <a:r>
               <a:rPr lang="en-US" b="1" dirty="0"/>
-              <a:t>Problem statement</a:t>
+              <a:t>Research paper implementation</a:t>
             </a:r>
           </a:p>
           <a:p>
             <a:r>
               <a:rPr lang="en-US" b="1" dirty="0"/>
-              <a:t>Anchor paper &amp; related work</a:t>
+              <a:t>Architecture diagram</a:t>
             </a:r>
           </a:p>
           <a:p>
             <a:r>
               <a:rPr lang="en-US" b="1" dirty="0"/>
-              <a:t>Dataset — Spider</a:t>
+              <a:t>GitHub code availability</a:t>
             </a:r>
           </a:p>
           <a:p>
             <a:r>
               <a:rPr lang="en-US" b="1" dirty="0"/>
-              <a:t>System architecture (CodeS pipeline)</a:t>
+              <a:t>Code execution &amp; reproduction results</a:t>
             </a:r>
           </a:p>
           <a:p>
             <a:r>
               <a:rPr lang="en-US" b="1" dirty="0"/>
-              <a:t>Environment, GitHub &amp; reproduction results</a:t>
+              <a:t>Contributions</a:t>
             </a:r>
           </a:p>
           <a:p>
             <a:r>
               <a:rPr lang="en-US" b="1" dirty="0"/>
-              <a:t>Contributions &amp; enhancements (next-review work)</a:t>
+              <a:t>Reproducibility documentation (10 pages)</a:t>
             </a:r>
           </a:p>
           <a:p>
             <a:r>
               <a:rPr lang="en-US" b="1" dirty="0"/>
-              <a:t>References</a:t>
+              <a:t>Enhancements / improvements &amp; next-review work</a:t>
             </a:r>
           </a:p>
         </p:txBody>
@@ -4636,19 +4636,7 @@
                   <a:srgbClr val="002060"/>
                 </a:solidFill>
               </a:rPr>
-              <a:t>Problem </a:t>
-            </a:r>
-            <a:r>
-              <a:rPr lang="en-US" dirty="0"/>
-              <a:t>S</a:t>
-            </a:r>
-            <a:r>
-              <a:rPr lang="en-US" b="1" dirty="0">
-                <a:solidFill>
-                  <a:srgbClr val="002060"/>
-                </a:solidFill>
-              </a:rPr>
-              <a:t>tatement</a:t>
+              <a:t>Research Paper Implementation</a:t>
             </a:r>
           </a:p>
         </p:txBody>
@@ -4671,12 +4659,24 @@
         </p:nvSpPr>
         <p:spPr/>
         <p:txBody>
-          <a:bodyPr/>
+          <a:bodyPr wrap="square"/>
           <a:lstStyle/>
           <a:p>
             <a:r>
               <a:rPr lang="en-US" b="1" dirty="0"/>
-              <a:t>Natural-language-to-SQL lets non-technical users query a database in plain English (e.g. “which students failed more than two subjects?” → SQL → results). State-of-the-art systems rely on closed-source LLMs (GPT-4), which bring unclear architectures, data-privacy risk (the schema is sent to a third party) and high inference cost. QueryGenie reproduces CodeS — a fully open-source model that runs locally — and adds trustworthiness: execution-guided self-correction and confidence-aware abstention.</a:t>
+              <a:t>Anchor paper — CodeS (SIGMOD 2024, arXiv:2402.16347): a fully open-source text-to-SQL model (StarCoder base, incremental pre-training, schema filter + value retriever, supervised fine-tuning). We implement its inference pipeline end-to-end and reproduce it on the Spider benchmark.</a:t>
+            </a:r>
+          </a:p>
+          <a:p>
+            <a:r>
+              <a:rPr lang="en-US" b="1" dirty="0"/>
+              <a:t>Two-tier reproduction:  Tier 1 (liveness) — the released codes-1b loads, generates SQL from a schema + question, and executes it (Week-4 red-flag gate: CLEARED).  Tier 2 (faithful) — Spider-dev Execution-Accuracy evaluation with the released CodeS-1B checkpoint.</a:t>
+            </a:r>
+          </a:p>
+          <a:p>
+            <a:r>
+              <a:rPr lang="en-US" b="1" dirty="0"/>
+              <a:t>Working prototype:  a local app (Gradio) runs the full pipeline on-device — natural-language question → CodeS → SQL → execute → self-correct on failure → results table + auto-selected chart. Nothing leaves the machine.</a:t>
             </a:r>
           </a:p>
         </p:txBody>
@@ -4740,7 +4740,7 @@
                 </a:solidFill>
                 <a:latin typeface="+mn-lt"/>
               </a:rPr>
-              <a:t>Related Research Papers</a:t>
+              <a:t>Code Execution &amp; Reproduction Results</a:t>
             </a:r>
           </a:p>
         </p:txBody>
@@ -4819,8 +4819,7 @@
                     <a:lstStyle/>
                     <a:p>
                       <a:r>
-                        <a:rPr lang="en-US" dirty="0"/>
-                        <a:t>Paper Title</a:t>
+                        <a:t>Item</a:t>
                       </a:r>
                     </a:p>
                   </a:txBody>
@@ -4832,22 +4831,7 @@
                     <a:lstStyle/>
                     <a:p>
                       <a:r>
-                        <a:rPr lang="en-US" dirty="0"/>
-                        <a:t>Problem Addressed</a:t>
-                      </a:r>
-                    </a:p>
-                  </a:txBody>
-                  <a:tcPr/>
-                </a:tc>
-                <a:tc>
-                  <a:txBody>
-                    <a:bodyPr/>
-                    <a:lstStyle/>
-                    <a:p>
-                      <a:pPr algn="ctr"/>
-                      <a:r>
-                        <a:rPr lang="en-US" dirty="0"/>
-                        <a:t>Dataset(s) if any</a:t>
+                        <a:t>Setup</a:t>
                       </a:r>
                     </a:p>
                   </a:txBody>
@@ -4859,8 +4843,7 @@
                     <a:lstStyle/>
                     <a:p>
                       <a:r>
-                        <a:rPr lang="en-US" dirty="0"/>
-                        <a:t>Methodology</a:t>
+                        <a:t>Metric</a:t>
                       </a:r>
                     </a:p>
                   </a:txBody>
@@ -4872,8 +4855,19 @@
                     <a:lstStyle/>
                     <a:p>
                       <a:r>
-                        <a:rPr lang="en-US" dirty="0"/>
-                        <a:t>Results</a:t>
+                        <a:t>Result</a:t>
+                      </a:r>
+                    </a:p>
+                  </a:txBody>
+                  <a:tcPr/>
+                </a:tc>
+                <a:tc>
+                  <a:txBody>
+                    <a:bodyPr/>
+                    <a:lstStyle/>
+                    <a:p>
+                      <a:r>
+                        <a:t>Status</a:t>
                       </a:r>
                     </a:p>
                   </a:txBody>
@@ -4892,7 +4886,7 @@
                     <a:lstStyle/>
                     <a:p>
                       <a:r>
-                        <a:t>CodeS (SIGMOD 2024)</a:t>
+                        <a:t>Tier-1 gate</a:t>
                       </a:r>
                     </a:p>
                   </a:txBody>
@@ -4904,7 +4898,7 @@
                     <a:lstStyle/>
                     <a:p>
                       <a:r>
-                        <a:t>Open-source text-to-SQL vs closed GPT-4</a:t>
+                        <a:t>codes-1b · Colab T4</a:t>
                       </a:r>
                     </a:p>
                   </a:txBody>
@@ -4916,7 +4910,7 @@
                     <a:lstStyle/>
                     <a:p>
                       <a:r>
-                        <a:t>Spider, BIRD</a:t>
+                        <a:t>SQL executes</a:t>
                       </a:r>
                     </a:p>
                   </a:txBody>
@@ -4928,7 +4922,7 @@
                     <a:lstStyle/>
                     <a:p>
                       <a:r>
-                        <a:t>StarCoder + incremental pre-training + schema filter + SFT</a:t>
+                        <a:t>Correct row returned</a:t>
                       </a:r>
                     </a:p>
                   </a:txBody>
@@ -4940,7 +4934,7 @@
                     <a:lstStyle/>
                     <a:p>
                       <a:r>
-                        <a:t>New SOTA; CodeS-1B = 77.9% EX on Spider dev</a:t>
+                        <a:t>Cleared (T1-001)</a:t>
                       </a:r>
                     </a:p>
                   </a:txBody>
@@ -4959,7 +4953,7 @@
                     <a:lstStyle/>
                     <a:p>
                       <a:r>
-                        <a:t>RESDSQL (AAAI 2023)</a:t>
+                        <a:t>Prototype</a:t>
                       </a:r>
                     </a:p>
                   </a:txBody>
@@ -4971,7 +4965,7 @@
                     <a:lstStyle/>
                     <a:p>
                       <a:r>
-                        <a:t>Schema linking &amp; skeleton parsing</a:t>
+                        <a:t>codes-3b-spider · Apple M4</a:t>
                       </a:r>
                     </a:p>
                   </a:txBody>
@@ -4983,7 +4977,7 @@
                     <a:lstStyle/>
                     <a:p>
                       <a:r>
-                        <a:t>Spider</a:t>
+                        <a:t>Example queries</a:t>
                       </a:r>
                     </a:p>
                   </a:txBody>
@@ -4995,7 +4989,7 @@
                     <a:lstStyle/>
                     <a:p>
                       <a:r>
-                        <a:t>Ranking-enhanced encoder + NatSQL decoding</a:t>
+                        <a:t>Correct SQL + auto chart</a:t>
                       </a:r>
                     </a:p>
                   </a:txBody>
@@ -5007,7 +5001,7 @@
                     <a:lstStyle/>
                     <a:p>
                       <a:r>
-                        <a:t>Strong Spider EX; our backup anchor</a:t>
+                        <a:t>Working</a:t>
                       </a:r>
                     </a:p>
                   </a:txBody>
@@ -5026,7 +5020,7 @@
                     <a:lstStyle/>
                     <a:p>
                       <a:r>
-                        <a:t>DIN-SQL (NeurIPS 2023)</a:t>
+                        <a:t>Tier-2 (Spider dev)</a:t>
                       </a:r>
                     </a:p>
                   </a:txBody>
@@ -5038,7 +5032,7 @@
                     <a:lstStyle/>
                     <a:p>
                       <a:r>
-                        <a:t>Hard text-to-SQL via decomposition</a:t>
+                        <a:t>codes-1b-spider</a:t>
                       </a:r>
                     </a:p>
                   </a:txBody>
@@ -5050,7 +5044,7 @@
                     <a:lstStyle/>
                     <a:p>
                       <a:r>
-                        <a:t>Spider, BIRD</a:t>
+                        <a:t>Execution Accuracy</a:t>
                       </a:r>
                     </a:p>
                   </a:txBody>
@@ -5062,7 +5056,7 @@
                     <a:lstStyle/>
                     <a:p>
                       <a:r>
-                        <a:t>Decomposed in-context learning + self-correction</a:t>
+                        <a:t>73.3% (prelim, 30 ex)</a:t>
                       </a:r>
                     </a:p>
                   </a:txBody>
@@ -5074,7 +5068,7 @@
                     <a:lstStyle/>
                     <a:p>
                       <a:r>
-                        <a:t>SOTA with GPT-4; source of our self-correction</a:t>
+                        <a:t>Full run completing</a:t>
                       </a:r>
                     </a:p>
                   </a:txBody>
@@ -5093,7 +5087,7 @@
                     <a:lstStyle/>
                     <a:p>
                       <a:r>
-                        <a:t>LIDA (ACL 2023)</a:t>
+                        <a:t>Paper target</a:t>
                       </a:r>
                     </a:p>
                   </a:txBody>
@@ -5105,7 +5099,7 @@
                     <a:lstStyle/>
                     <a:p>
                       <a:r>
-                        <a:t>Automatic visualization from data</a:t>
+                        <a:t>CodeS-1B · Spider dev</a:t>
                       </a:r>
                     </a:p>
                   </a:txBody>
@@ -5117,7 +5111,7 @@
                     <a:lstStyle/>
                     <a:p>
                       <a:r>
-                        <a:t>—</a:t>
+                        <a:t>EX (Table 5)</a:t>
                       </a:r>
                     </a:p>
                   </a:txBody>
@@ -5129,7 +5123,7 @@
                     <a:lstStyle/>
                     <a:p>
                       <a:r>
-                        <a:t>LLM grammar-agnostic visualization generation</a:t>
+                        <a:t>77.9%</a:t>
                       </a:r>
                     </a:p>
                   </a:txBody>
@@ -5141,7 +5135,7 @@
                     <a:lstStyle/>
                     <a:p>
                       <a:r>
-                        <a:t>Auto chart selection in the QueryGenie UI</a:t>
+                        <a:t>Within ±10% tolerance</a:t>
                       </a:r>
                     </a:p>
                   </a:txBody>
@@ -5191,7 +5185,7 @@
             </a:pPr>
             <a:r>
               <a:rPr lang="en-US" dirty="0"/>
-              <a:t>Papers most relevant to QueryGenie: the anchor (reproduced), a backup anchor, the enhancement source, and the visualization layer.</a:t>
+              <a:t>Execution verified on real databases; Tier-2 measures Spider-dev Execution Accuracy vs the paper's 77.9%.</a:t>
             </a:r>
           </a:p>
         </p:txBody>
@@ -5254,7 +5248,7 @@
                   <a:srgbClr val="002060"/>
                 </a:solidFill>
               </a:rPr>
-              <a:t>Dataset(s)</a:t>
+              <a:t>GitHub Code Availability</a:t>
             </a:r>
             <a:endParaRPr lang="en-US" dirty="0">
               <a:solidFill>
@@ -5282,18 +5276,24 @@
         </p:nvSpPr>
         <p:spPr/>
         <p:txBody>
-          <a:bodyPr/>
+          <a:bodyPr wrap="square"/>
           <a:lstStyle/>
           <a:p>
             <a:r>
               <a:rPr lang="en-US" dirty="0"/>
-              <a:t>Spider (Yu et al., EMNLP 2018) — a large-scale, cross-domain text-to-SQL benchmark. Train 7,000 / development 1,034 examples across 166 databases; train and dev use disjoint databases, so the model must generalise to unseen schemas. Metrics: Execution Accuracy (EX) and Test-suite accuracy (TS).</a:t>
+              <a:t>Repository: github.com/jayakanthh/QueryGenie  (private; project supervisor and both team members added as collaborators — both commit under their own accounts).</a:t>
             </a:r>
           </a:p>
           <a:p>
             <a:r>
               <a:rPr lang="en-US" dirty="0"/>
-              <a:t>Source: Hugging Face Datasets (xlangai/spider) — an approved source; Kaggle is not used. Provenance is recorded in results/dataset_provenance.json.</a:t>
+              <a:t>Structure:  src/ — prototype (app.py, model.py, engine.py, database.py, charts.py);  scripts/ — download_spider.py, convert_mlx.py;  notebooks/ — Week-4 gate;  results/ — reproduction_log.csv + evidence;  docs/ — reproducibility report, architecture, weekly reports.</a:t>
+            </a:r>
+          </a:p>
+          <a:p>
+            <a:r>
+              <a:rPr lang="en-US" dirty="0"/>
+              <a:t>Run locally:  pip install -r requirements.txt  →  python src/app.py.  The dataset and model weights are fetched from approved sources (Hugging Face); large artefacts are git-ignored and regenerable.</a:t>
             </a:r>
           </a:p>
         </p:txBody>
@@ -5356,7 +5356,7 @@
                   <a:srgbClr val="002060"/>
                 </a:solidFill>
               </a:rPr>
-              <a:t>Architecture Diagram / Workflow</a:t>
+              <a:t>Architecture Diagram (CodeS pipeline)</a:t>
             </a:r>
             <a:endParaRPr lang="en-US" dirty="0">
               <a:solidFill>
@@ -5477,7 +5477,7 @@
                 </a:solidFill>
                 <a:latin typeface="Aptos" panose="020B0004020202020204" pitchFamily="34" charset="0"/>
               </a:rPr>
-              <a:t>Environment setup</a:t>
+              <a:t>Contributions</a:t>
             </a:r>
             <a:endParaRPr lang="en-US" b="1" dirty="0">
               <a:solidFill>
@@ -5505,12 +5505,30 @@
         </p:nvSpPr>
         <p:spPr/>
         <p:txBody>
-          <a:bodyPr/>
+          <a:bodyPr wrap="square"/>
           <a:lstStyle/>
           <a:p>
             <a:r>
               <a:rPr lang="en-US" dirty="0"/>
-              <a:t>Two-tier reproduction. Tier 1 (liveness) — CLEARED: the released codes-1b loaded on a Colab T4, generated valid SQL and executed it on SQLite (run T1-001). Tier 2 (faithful): Spider-dev Execution-Accuracy evaluation with the released CodeS-1B checkpoint (inference-only — no CUDA training libraries needed). Preliminary EX: 73.3% (30 dev examples, 100% executed); the full 1034-example run is completing — paper target 77.9%, within the ±10% tolerance. A working local prototype (Gradio) turns a question into SQL, executes it, self-corrects on failure, and shows a results table + auto chart, running fully on-device (MLX / GGUF). GitHub: github.com/jayakanthh/QueryGenie (supervisor added as collaborator).</a:t>
+              <a:t>1) Execution-guided self-correction — detect SQL that fails to execute and repair it automatically (prototype already built; formalised and measured in Month 3).</a:t>
+            </a:r>
+          </a:p>
+          <a:p>
+            <a:r>
+              <a:rPr lang="en-US" dirty="0"/>
+              <a:t>2) Confidence-aware abstention (novel) — generate multiple candidates, measure their agreement, and abstain with a clarifying question when confidence is low; reported as an accuracy-vs-coverage curve. Existing systems answer with uniform confidence and never report this.</a:t>
+            </a:r>
+          </a:p>
+          <a:p>
+            <a:r>
+              <a:rPr lang="en-US" dirty="0"/>
+              <a:t>3) Benchmark-to-reality gap — evaluate on a custom academic schema alongside Spider to quantify and narrow the drop published models show on real databases.</a:t>
+            </a:r>
+          </a:p>
+          <a:p>
+            <a:r>
+              <a:rPr lang="en-US" dirty="0"/>
+              <a:t>Each enhancement is measured against the reproduced baseline with statistical significance (paired t-test / Wilcoxon).</a:t>
             </a:r>
           </a:p>
         </p:txBody>
@@ -5573,7 +5591,7 @@
                   <a:srgbClr val="002060"/>
                 </a:solidFill>
               </a:rPr>
-              <a:t>Expected Outcome</a:t>
+              <a:t>Enhancements, Improvements &amp; Next-Review Work</a:t>
             </a:r>
             <a:endParaRPr lang="en-US" dirty="0">
               <a:solidFill>
@@ -5601,19 +5619,25 @@
         </p:nvSpPr>
         <p:spPr/>
         <p:txBody>
-          <a:bodyPr/>
+          <a:bodyPr wrap="square"/>
           <a:lstStyle/>
           <a:p>
             <a:r>
               <a:rPr lang="en-US" b="1" dirty="0"/>
-              <a:t>Planned enhancements (each measured vs the reproduced baseline; significance via t-test / Wilcoxon): (1) Execution-guided self-correction — repair SQL that fails to execute (prototype built). (2) Confidence-aware abstention (novel) — generate multiple candidates and abstain with a clarifying question when they disagree; report an accuracy-vs-coverage curve. (3) Benchmark-to-reality gap — evaluate on a custom academic schema alongside Spider and narrow the drop real databases show. Next-review work: complete the full Spider-dev run and log three runs; Week-7 schema-filter ablation; Reproducibility Report v2 with measured numbers.</a:t>
-            </a:r>
-          </a:p>
-          <a:p>
-            <a:pPr marL="0" indent="0">
-              <a:buNone/>
-            </a:pPr>
-            <a:endParaRPr lang="en-US" dirty="0"/>
+              <a:t>Reproducibility documentation: a 10-page Code Reproducibility Report accompanies this review (scope, environment, executed runs, documented deviations, metrics, artefact index).</a:t>
+            </a:r>
+          </a:p>
+          <a:p>
+            <a:r>
+              <a:rPr lang="en-US" b="1" dirty="0"/>
+              <a:t>Improvement to close the reproduction gap: adopt the full CodeS database prompt (schema filter + BM25 value retriever + metadata) to move EX from 73.3% toward the reported 77.9%.</a:t>
+            </a:r>
+          </a:p>
+          <a:p>
+            <a:r>
+              <a:rPr lang="en-US" b="1" dirty="0"/>
+              <a:t>Next-review work: complete the full 1034-example Spider-dev run and log three runs; finalise EX vs the 77.9% target; Week-7 schema-filter ablation; begin the enhancement implementation (self-correction → confidence-aware abstention).</a:t>
+            </a:r>
           </a:p>
         </p:txBody>
       </p:sp>

</xml_diff>

<commit_message>
Tier-2 result: Spider dev EX = 64.8% (full 1034), documented gap
Full Spider-dev evaluation of codes-1b-spider (run T2-001): EX 64.8% (670/1034,
92.9% executed) vs paper 77.9% — outside +/-10% tolerance, documented cause:
schema+FK prompt instead of the authors' full database prompt (schema filter +
BM25 value retriever + metadata) the SFT model expects. Honest reporting per SOP.

- Deck: results table + enhancement slide updated to 64.8% with the cause
- Reproducibility report: Tier-2 section now reports the executed result + gap
  analysis + improvement plan; Appendix A.1 logs T2-001
- DELIVERABLES: Month-2 reproduction rows updated

Co-Authored-By: Claude Opus 4.8 <noreply@anthropic.com>
</commit_message>
<xml_diff>
--- a/docs/reviews/Review2_QueryGenie.pptx
+++ b/docs/reviews/Review2_QueryGenie.pptx
@@ -3675,127 +3675,6 @@
           <a:chExt cx="0" cy="0"/>
         </a:xfrm>
       </p:grpSpPr>
-      <p:sp>
-        <p:nvSpPr>
-          <p:cNvPr id="2" name="Title 1">
-            <a:extLst>
-              <a:ext uri="{FF2B5EF4-FFF2-40B4-BE49-F238E27FC236}">
-                <a16:creationId xmlns:a16="http://schemas.microsoft.com/office/drawing/2014/main" id="{6CC3C1D4-A931-668D-A188-5C11E68A1302}"/>
-              </a:ext>
-            </a:extLst>
-          </p:cNvPr>
-          <p:cNvSpPr>
-            <a:spLocks noGrp="1"/>
-          </p:cNvSpPr>
-          <p:nvPr>
-            <p:ph type="title"/>
-          </p:nvPr>
-        </p:nvSpPr>
-        <p:spPr/>
-        <p:txBody>
-          <a:bodyPr/>
-          <a:lstStyle/>
-          <a:p>
-            <a:pPr algn="ctr"/>
-            <a:r>
-              <a:rPr lang="en-US" b="1" dirty="0">
-                <a:solidFill>
-                  <a:srgbClr val="002060"/>
-                </a:solidFill>
-              </a:rPr>
-              <a:t>References</a:t>
-            </a:r>
-          </a:p>
-        </p:txBody>
-      </p:sp>
-      <p:sp>
-        <p:nvSpPr>
-          <p:cNvPr id="3" name="Content Placeholder 2">
-            <a:extLst>
-              <a:ext uri="{FF2B5EF4-FFF2-40B4-BE49-F238E27FC236}">
-                <a16:creationId xmlns:a16="http://schemas.microsoft.com/office/drawing/2014/main" id="{E4A35C1D-7495-EB2D-9FA3-079F416634F4}"/>
-              </a:ext>
-            </a:extLst>
-          </p:cNvPr>
-          <p:cNvSpPr>
-            <a:spLocks noGrp="1"/>
-          </p:cNvSpPr>
-          <p:nvPr>
-            <p:ph idx="1"/>
-          </p:nvPr>
-        </p:nvSpPr>
-        <p:spPr/>
-        <p:txBody>
-          <a:bodyPr wrap="square"/>
-          <a:lstStyle/>
-          <a:p>
-            <a:r>
-              <a:rPr lang="en-US" dirty="0"/>
-              <a:t>Li, H., et al. (2024). CodeS: Towards Building Open-source Language Models for Text-to-SQL. SIGMOD. arXiv:2402.16347</a:t>
-            </a:r>
-          </a:p>
-          <a:p>
-            <a:r>
-              <a:rPr lang="en-US" dirty="0"/>
-              <a:t>Li, H., et al. (2023). RESDSQL: Decoupling Schema Linking and Skeleton Parsing for Text-to-SQL. AAAI. arXiv:2302.05965</a:t>
-            </a:r>
-          </a:p>
-          <a:p>
-            <a:r>
-              <a:rPr lang="en-US" dirty="0"/>
-              <a:t>Pourreza, M., &amp; Rafiei, D. (2023). DIN-SQL: Decomposed In-Context Learning of Text-to-SQL with Self-Correction. NeurIPS. arXiv:2304.11015</a:t>
-            </a:r>
-          </a:p>
-          <a:p>
-            <a:r>
-              <a:rPr lang="en-US" dirty="0"/>
-              <a:t>Dibia, V. (2023). LIDA: Automatic Generation of Grammar-Agnostic Visualizations using LLMs. ACL. arXiv:2303.02927</a:t>
-            </a:r>
-          </a:p>
-          <a:p>
-            <a:r>
-              <a:rPr lang="en-US" dirty="0"/>
-              <a:t>Yu, T., et al. (2018). Spider: A Large-Scale Dataset for Complex and Cross-Domain Text-to-SQL. EMNLP. arXiv:1809.08887</a:t>
-            </a:r>
-          </a:p>
-          <a:p>
-            <a:r>
-              <a:rPr lang="en-US" dirty="0"/>
-              <a:t>Li, R., et al. (2023). StarCoder: may the source be with you! arXiv:2305.06161</a:t>
-            </a:r>
-          </a:p>
-        </p:txBody>
-      </p:sp>
-    </p:spTree>
-    <p:extLst>
-      <p:ext uri="{BB962C8B-B14F-4D97-AF65-F5344CB8AC3E}">
-        <p14:creationId xmlns:p14="http://schemas.microsoft.com/office/powerpoint/2010/main" val="2237049153"/>
-      </p:ext>
-    </p:extLst>
-  </p:cSld>
-  <p:clrMapOvr>
-    <a:masterClrMapping/>
-  </p:clrMapOvr>
-</p:sld>
-</file>
-
-<file path=ppt/slides/slide11.xml><?xml version="1.0" encoding="utf-8"?>
-<p:sld xmlns:a="http://schemas.openxmlformats.org/drawingml/2006/main" xmlns:r="http://schemas.openxmlformats.org/officeDocument/2006/relationships" xmlns:p="http://schemas.openxmlformats.org/presentationml/2006/main">
-  <p:cSld>
-    <p:spTree>
-      <p:nvGrpSpPr>
-        <p:cNvPr id="1" name=""/>
-        <p:cNvGrpSpPr/>
-        <p:nvPr/>
-      </p:nvGrpSpPr>
-      <p:grpSpPr>
-        <a:xfrm>
-          <a:off x="0" y="0"/>
-          <a:ext cx="0" cy="0"/>
-          <a:chOff x="0" y="0"/>
-          <a:chExt cx="0" cy="0"/>
-        </a:xfrm>
-      </p:grpSpPr>
       <p:sp useBgFill="1">
         <p:nvSpPr>
           <p:cNvPr id="7" name="Rectangle 6">
@@ -4695,6 +4574,234 @@
 </file>
 
 <file path=ppt/slides/slide4.xml><?xml version="1.0" encoding="utf-8"?>
+<p:sld xmlns:a="http://schemas.openxmlformats.org/drawingml/2006/main" xmlns:r="http://schemas.openxmlformats.org/officeDocument/2006/relationships" xmlns:p="http://schemas.openxmlformats.org/presentationml/2006/main">
+  <p:cSld>
+    <p:spTree>
+      <p:nvGrpSpPr>
+        <p:cNvPr id="1" name=""/>
+        <p:cNvGrpSpPr/>
+        <p:nvPr/>
+      </p:nvGrpSpPr>
+      <p:grpSpPr>
+        <a:xfrm>
+          <a:off x="0" y="0"/>
+          <a:ext cx="0" cy="0"/>
+          <a:chOff x="0" y="0"/>
+          <a:chExt cx="0" cy="0"/>
+        </a:xfrm>
+      </p:grpSpPr>
+      <p:sp>
+        <p:nvSpPr>
+          <p:cNvPr id="2" name="Title 1">
+            <a:extLst>
+              <a:ext uri="{FF2B5EF4-FFF2-40B4-BE49-F238E27FC236}">
+                <a16:creationId xmlns:a16="http://schemas.microsoft.com/office/drawing/2014/main" id="{728E3DF0-FB58-63D4-45FC-2D647681FAAC}"/>
+              </a:ext>
+            </a:extLst>
+          </p:cNvPr>
+          <p:cNvSpPr>
+            <a:spLocks noGrp="1"/>
+          </p:cNvSpPr>
+          <p:nvPr>
+            <p:ph type="title"/>
+          </p:nvPr>
+        </p:nvSpPr>
+        <p:spPr/>
+        <p:txBody>
+          <a:bodyPr/>
+          <a:lstStyle/>
+          <a:p>
+            <a:pPr algn="ctr"/>
+            <a:r>
+              <a:rPr lang="en-US" b="1" dirty="0">
+                <a:solidFill>
+                  <a:srgbClr val="002060"/>
+                </a:solidFill>
+              </a:rPr>
+              <a:t>Architecture Diagram (CodeS pipeline)</a:t>
+            </a:r>
+            <a:endParaRPr lang="en-US" dirty="0">
+              <a:solidFill>
+                <a:srgbClr val="002060"/>
+              </a:solidFill>
+            </a:endParaRPr>
+          </a:p>
+        </p:txBody>
+      </p:sp>
+      <p:sp>
+        <p:nvSpPr>
+          <p:cNvPr id="3" name="Content Placeholder 2">
+            <a:extLst>
+              <a:ext uri="{FF2B5EF4-FFF2-40B4-BE49-F238E27FC236}">
+                <a16:creationId xmlns:a16="http://schemas.microsoft.com/office/drawing/2014/main" id="{F5B99294-2DD4-54FB-DEAC-067E7BB887D3}"/>
+              </a:ext>
+            </a:extLst>
+          </p:cNvPr>
+          <p:cNvSpPr>
+            <a:spLocks noGrp="1"/>
+          </p:cNvSpPr>
+          <p:nvPr>
+            <p:ph idx="1"/>
+          </p:nvPr>
+        </p:nvSpPr>
+        <p:spPr/>
+        <p:txBody>
+          <a:bodyPr/>
+          <a:lstStyle/>
+          <a:p>
+            <a:r>
+              <a:rPr lang="en-US" dirty="0"/>
+              <a:t/>
+            </a:r>
+          </a:p>
+        </p:txBody>
+      </p:sp>
+      <p:pic>
+        <p:nvPicPr>
+          <p:cNvPr id="4" name="Picture 3" descr="codes_architecture_flowchart.png"/>
+          <p:cNvPicPr>
+            <a:picLocks noChangeAspect="1"/>
+          </p:cNvPicPr>
+          <p:nvPr/>
+        </p:nvPicPr>
+        <p:blipFill>
+          <a:blip r:embed="rId2"/>
+          <a:stretch>
+            <a:fillRect/>
+          </a:stretch>
+        </p:blipFill>
+        <p:spPr>
+          <a:xfrm>
+            <a:off x="2832496" y="1825625"/>
+            <a:ext cx="6527007" cy="4351338"/>
+          </a:xfrm>
+          <a:prstGeom prst="rect">
+            <a:avLst/>
+          </a:prstGeom>
+        </p:spPr>
+      </p:pic>
+    </p:spTree>
+    <p:extLst>
+      <p:ext uri="{BB962C8B-B14F-4D97-AF65-F5344CB8AC3E}">
+        <p14:creationId xmlns:p14="http://schemas.microsoft.com/office/powerpoint/2010/main" val="28790724"/>
+      </p:ext>
+    </p:extLst>
+  </p:cSld>
+  <p:clrMapOvr>
+    <a:masterClrMapping/>
+  </p:clrMapOvr>
+</p:sld>
+</file>
+
+<file path=ppt/slides/slide5.xml><?xml version="1.0" encoding="utf-8"?>
+<p:sld xmlns:a="http://schemas.openxmlformats.org/drawingml/2006/main" xmlns:r="http://schemas.openxmlformats.org/officeDocument/2006/relationships" xmlns:p="http://schemas.openxmlformats.org/presentationml/2006/main">
+  <p:cSld>
+    <p:spTree>
+      <p:nvGrpSpPr>
+        <p:cNvPr id="1" name=""/>
+        <p:cNvGrpSpPr/>
+        <p:nvPr/>
+      </p:nvGrpSpPr>
+      <p:grpSpPr>
+        <a:xfrm>
+          <a:off x="0" y="0"/>
+          <a:ext cx="0" cy="0"/>
+          <a:chOff x="0" y="0"/>
+          <a:chExt cx="0" cy="0"/>
+        </a:xfrm>
+      </p:grpSpPr>
+      <p:sp>
+        <p:nvSpPr>
+          <p:cNvPr id="2" name="Title 1">
+            <a:extLst>
+              <a:ext uri="{FF2B5EF4-FFF2-40B4-BE49-F238E27FC236}">
+                <a16:creationId xmlns:a16="http://schemas.microsoft.com/office/drawing/2014/main" id="{C825DDE0-8A2C-ED6B-154D-D21691F720B1}"/>
+              </a:ext>
+            </a:extLst>
+          </p:cNvPr>
+          <p:cNvSpPr>
+            <a:spLocks noGrp="1"/>
+          </p:cNvSpPr>
+          <p:nvPr>
+            <p:ph type="title"/>
+          </p:nvPr>
+        </p:nvSpPr>
+        <p:spPr/>
+        <p:txBody>
+          <a:bodyPr/>
+          <a:lstStyle/>
+          <a:p>
+            <a:pPr algn="ctr"/>
+            <a:r>
+              <a:rPr lang="en-US" b="1" dirty="0">
+                <a:solidFill>
+                  <a:srgbClr val="002060"/>
+                </a:solidFill>
+              </a:rPr>
+              <a:t>GitHub Code Availability</a:t>
+            </a:r>
+            <a:endParaRPr lang="en-US" dirty="0">
+              <a:solidFill>
+                <a:srgbClr val="002060"/>
+              </a:solidFill>
+            </a:endParaRPr>
+          </a:p>
+        </p:txBody>
+      </p:sp>
+      <p:sp>
+        <p:nvSpPr>
+          <p:cNvPr id="3" name="Content Placeholder 2">
+            <a:extLst>
+              <a:ext uri="{FF2B5EF4-FFF2-40B4-BE49-F238E27FC236}">
+                <a16:creationId xmlns:a16="http://schemas.microsoft.com/office/drawing/2014/main" id="{E8C3DDA3-3837-1013-1D85-7CA3CDCC80E0}"/>
+              </a:ext>
+            </a:extLst>
+          </p:cNvPr>
+          <p:cNvSpPr>
+            <a:spLocks noGrp="1"/>
+          </p:cNvSpPr>
+          <p:nvPr>
+            <p:ph idx="1"/>
+          </p:nvPr>
+        </p:nvSpPr>
+        <p:spPr/>
+        <p:txBody>
+          <a:bodyPr wrap="square"/>
+          <a:lstStyle/>
+          <a:p>
+            <a:r>
+              <a:rPr lang="en-US" dirty="0"/>
+              <a:t>Repository: github.com/jayakanthh/QueryGenie  (private; project supervisor and both team members added as collaborators — both commit under their own accounts).</a:t>
+            </a:r>
+          </a:p>
+          <a:p>
+            <a:r>
+              <a:rPr lang="en-US" dirty="0"/>
+              <a:t>Structure:  src/ — prototype (app.py, model.py, engine.py, database.py, charts.py);  scripts/ — download_spider.py, convert_mlx.py;  notebooks/ — Week-4 gate;  results/ — reproduction_log.csv + evidence;  docs/ — reproducibility report, architecture, weekly reports.</a:t>
+            </a:r>
+          </a:p>
+          <a:p>
+            <a:r>
+              <a:rPr lang="en-US" dirty="0"/>
+              <a:t>Run locally:  pip install -r requirements.txt  →  python src/app.py.  The dataset and model weights are fetched from approved sources (Hugging Face); large artefacts are git-ignored and regenerable.</a:t>
+            </a:r>
+          </a:p>
+        </p:txBody>
+      </p:sp>
+    </p:spTree>
+    <p:extLst>
+      <p:ext uri="{BB962C8B-B14F-4D97-AF65-F5344CB8AC3E}">
+        <p14:creationId xmlns:p14="http://schemas.microsoft.com/office/powerpoint/2010/main" val="3765852975"/>
+      </p:ext>
+    </p:extLst>
+  </p:cSld>
+  <p:clrMapOvr>
+    <a:masterClrMapping/>
+  </p:clrMapOvr>
+</p:sld>
+</file>
+
+<file path=ppt/slides/slide6.xml><?xml version="1.0" encoding="utf-8"?>
 <p:sld xmlns:a="http://schemas.openxmlformats.org/drawingml/2006/main" xmlns:r="http://schemas.openxmlformats.org/officeDocument/2006/relationships" xmlns:p="http://schemas.openxmlformats.org/presentationml/2006/main">
   <p:cSld>
     <p:spTree>
@@ -5056,7 +5163,7 @@
                     <a:lstStyle/>
                     <a:p>
                       <a:r>
-                        <a:t>73.3% (prelim, 30 ex)</a:t>
+                        <a:t>64.8% (full 1034 dev)</a:t>
                       </a:r>
                     </a:p>
                   </a:txBody>
@@ -5068,7 +5175,7 @@
                     <a:lstStyle/>
                     <a:p>
                       <a:r>
-                        <a:t>Full run completing</a:t>
+                        <a:t>Outside ±10%; documented cause</a:t>
                       </a:r>
                     </a:p>
                   </a:txBody>
@@ -5135,7 +5242,7 @@
                     <a:lstStyle/>
                     <a:p>
                       <a:r>
-                        <a:t>Within ±10% tolerance</a:t>
+                        <a:t>Gap −13.1 pts (prompt fidelity)</a:t>
                       </a:r>
                     </a:p>
                   </a:txBody>
@@ -5185,7 +5292,7 @@
             </a:pPr>
             <a:r>
               <a:rPr lang="en-US" dirty="0"/>
-              <a:t>Execution verified on real databases; Tier-2 measures Spider-dev Execution Accuracy vs the paper's 77.9%.</a:t>
+              <a:t>Full Spider-dev EX = 64.8% (670/1034; 92.9% executed) vs the paper's 77.9%. The gap is a documented deviation: our prompt is schema+FK only, not the authors' full database prompt (schema filter + BM25 value retriever + metadata) that the SFT model expects. Adopting the full prompt is the planned improvement.</a:t>
             </a:r>
           </a:p>
         </p:txBody>
@@ -5194,114 +5301,6 @@
     <p:extLst>
       <p:ext uri="{BB962C8B-B14F-4D97-AF65-F5344CB8AC3E}">
         <p14:creationId xmlns:p14="http://schemas.microsoft.com/office/powerpoint/2010/main" val="3957907177"/>
-      </p:ext>
-    </p:extLst>
-  </p:cSld>
-  <p:clrMapOvr>
-    <a:masterClrMapping/>
-  </p:clrMapOvr>
-</p:sld>
-</file>
-
-<file path=ppt/slides/slide6.xml><?xml version="1.0" encoding="utf-8"?>
-<p:sld xmlns:a="http://schemas.openxmlformats.org/drawingml/2006/main" xmlns:r="http://schemas.openxmlformats.org/officeDocument/2006/relationships" xmlns:p="http://schemas.openxmlformats.org/presentationml/2006/main">
-  <p:cSld>
-    <p:spTree>
-      <p:nvGrpSpPr>
-        <p:cNvPr id="1" name=""/>
-        <p:cNvGrpSpPr/>
-        <p:nvPr/>
-      </p:nvGrpSpPr>
-      <p:grpSpPr>
-        <a:xfrm>
-          <a:off x="0" y="0"/>
-          <a:ext cx="0" cy="0"/>
-          <a:chOff x="0" y="0"/>
-          <a:chExt cx="0" cy="0"/>
-        </a:xfrm>
-      </p:grpSpPr>
-      <p:sp>
-        <p:nvSpPr>
-          <p:cNvPr id="2" name="Title 1">
-            <a:extLst>
-              <a:ext uri="{FF2B5EF4-FFF2-40B4-BE49-F238E27FC236}">
-                <a16:creationId xmlns:a16="http://schemas.microsoft.com/office/drawing/2014/main" id="{C825DDE0-8A2C-ED6B-154D-D21691F720B1}"/>
-              </a:ext>
-            </a:extLst>
-          </p:cNvPr>
-          <p:cNvSpPr>
-            <a:spLocks noGrp="1"/>
-          </p:cNvSpPr>
-          <p:nvPr>
-            <p:ph type="title"/>
-          </p:nvPr>
-        </p:nvSpPr>
-        <p:spPr/>
-        <p:txBody>
-          <a:bodyPr/>
-          <a:lstStyle/>
-          <a:p>
-            <a:pPr algn="ctr"/>
-            <a:r>
-              <a:rPr lang="en-US" b="1" dirty="0">
-                <a:solidFill>
-                  <a:srgbClr val="002060"/>
-                </a:solidFill>
-              </a:rPr>
-              <a:t>GitHub Code Availability</a:t>
-            </a:r>
-            <a:endParaRPr lang="en-US" dirty="0">
-              <a:solidFill>
-                <a:srgbClr val="002060"/>
-              </a:solidFill>
-            </a:endParaRPr>
-          </a:p>
-        </p:txBody>
-      </p:sp>
-      <p:sp>
-        <p:nvSpPr>
-          <p:cNvPr id="3" name="Content Placeholder 2">
-            <a:extLst>
-              <a:ext uri="{FF2B5EF4-FFF2-40B4-BE49-F238E27FC236}">
-                <a16:creationId xmlns:a16="http://schemas.microsoft.com/office/drawing/2014/main" id="{E8C3DDA3-3837-1013-1D85-7CA3CDCC80E0}"/>
-              </a:ext>
-            </a:extLst>
-          </p:cNvPr>
-          <p:cNvSpPr>
-            <a:spLocks noGrp="1"/>
-          </p:cNvSpPr>
-          <p:nvPr>
-            <p:ph idx="1"/>
-          </p:nvPr>
-        </p:nvSpPr>
-        <p:spPr/>
-        <p:txBody>
-          <a:bodyPr wrap="square"/>
-          <a:lstStyle/>
-          <a:p>
-            <a:r>
-              <a:rPr lang="en-US" dirty="0"/>
-              <a:t>Repository: github.com/jayakanthh/QueryGenie  (private; project supervisor and both team members added as collaborators — both commit under their own accounts).</a:t>
-            </a:r>
-          </a:p>
-          <a:p>
-            <a:r>
-              <a:rPr lang="en-US" dirty="0"/>
-              <a:t>Structure:  src/ — prototype (app.py, model.py, engine.py, database.py, charts.py);  scripts/ — download_spider.py, convert_mlx.py;  notebooks/ — Week-4 gate;  results/ — reproduction_log.csv + evidence;  docs/ — reproducibility report, architecture, weekly reports.</a:t>
-            </a:r>
-          </a:p>
-          <a:p>
-            <a:r>
-              <a:rPr lang="en-US" dirty="0"/>
-              <a:t>Run locally:  pip install -r requirements.txt  →  python src/app.py.  The dataset and model weights are fetched from approved sources (Hugging Face); large artefacts are git-ignored and regenerable.</a:t>
-            </a:r>
-          </a:p>
-        </p:txBody>
-      </p:sp>
-    </p:spTree>
-    <p:extLst>
-      <p:ext uri="{BB962C8B-B14F-4D97-AF65-F5344CB8AC3E}">
-        <p14:creationId xmlns:p14="http://schemas.microsoft.com/office/powerpoint/2010/main" val="3765852975"/>
       </p:ext>
     </p:extLst>
   </p:cSld>
@@ -5333,7 +5332,7 @@
           <p:cNvPr id="2" name="Title 1">
             <a:extLst>
               <a:ext uri="{FF2B5EF4-FFF2-40B4-BE49-F238E27FC236}">
-                <a16:creationId xmlns:a16="http://schemas.microsoft.com/office/drawing/2014/main" id="{728E3DF0-FB58-63D4-45FC-2D647681FAAC}"/>
+                <a16:creationId xmlns:a16="http://schemas.microsoft.com/office/drawing/2014/main" id="{E1601173-DB9D-2A55-1AC2-0B9A8596196D}"/>
               </a:ext>
             </a:extLst>
           </p:cNvPr>
@@ -5355,10 +5354,11 @@
                 <a:solidFill>
                   <a:srgbClr val="002060"/>
                 </a:solidFill>
+                <a:latin typeface="Aptos" panose="020B0004020202020204" pitchFamily="34" charset="0"/>
               </a:rPr>
-              <a:t>Architecture Diagram (CodeS pipeline)</a:t>
-            </a:r>
-            <a:endParaRPr lang="en-US" dirty="0">
+              <a:t>Contributions</a:t>
+            </a:r>
+            <a:endParaRPr lang="en-US" b="1" dirty="0">
               <a:solidFill>
                 <a:srgbClr val="002060"/>
               </a:solidFill>
@@ -5371,7 +5371,7 @@
           <p:cNvPr id="3" name="Content Placeholder 2">
             <a:extLst>
               <a:ext uri="{FF2B5EF4-FFF2-40B4-BE49-F238E27FC236}">
-                <a16:creationId xmlns:a16="http://schemas.microsoft.com/office/drawing/2014/main" id="{F5B99294-2DD4-54FB-DEAC-067E7BB887D3}"/>
+                <a16:creationId xmlns:a16="http://schemas.microsoft.com/office/drawing/2014/main" id="{05E775B2-4CCF-E3CC-67EB-BAFDAAE3AD8B}"/>
               </a:ext>
             </a:extLst>
           </p:cNvPr>
@@ -5384,44 +5384,38 @@
         </p:nvSpPr>
         <p:spPr/>
         <p:txBody>
-          <a:bodyPr/>
+          <a:bodyPr wrap="square"/>
           <a:lstStyle/>
           <a:p>
             <a:r>
               <a:rPr lang="en-US" dirty="0"/>
-              <a:t/>
-            </a:r>
-          </a:p>
-        </p:txBody>
-      </p:sp>
-      <p:pic>
-        <p:nvPicPr>
-          <p:cNvPr id="4" name="Picture 3" descr="codes_architecture_flowchart.png"/>
-          <p:cNvPicPr>
-            <a:picLocks noChangeAspect="1"/>
-          </p:cNvPicPr>
-          <p:nvPr/>
-        </p:nvPicPr>
-        <p:blipFill>
-          <a:blip r:embed="rId2"/>
-          <a:stretch>
-            <a:fillRect/>
-          </a:stretch>
-        </p:blipFill>
-        <p:spPr>
-          <a:xfrm>
-            <a:off x="2832496" y="1825625"/>
-            <a:ext cx="6527007" cy="4351338"/>
-          </a:xfrm>
-          <a:prstGeom prst="rect">
-            <a:avLst/>
-          </a:prstGeom>
-        </p:spPr>
-      </p:pic>
+              <a:t>1) Execution-guided self-correction — detect SQL that fails to execute and repair it automatically (prototype already built; formalised and measured in Month 3).</a:t>
+            </a:r>
+          </a:p>
+          <a:p>
+            <a:r>
+              <a:rPr lang="en-US" dirty="0"/>
+              <a:t>2) Confidence-aware abstention (novel) — generate multiple candidates, measure their agreement, and abstain with a clarifying question when confidence is low; reported as an accuracy-vs-coverage curve. Existing systems answer with uniform confidence and never report this.</a:t>
+            </a:r>
+          </a:p>
+          <a:p>
+            <a:r>
+              <a:rPr lang="en-US" dirty="0"/>
+              <a:t>3) Benchmark-to-reality gap — evaluate on a custom academic schema alongside Spider to quantify and narrow the drop published models show on real databases.</a:t>
+            </a:r>
+          </a:p>
+          <a:p>
+            <a:r>
+              <a:rPr lang="en-US" dirty="0"/>
+              <a:t>Each enhancement is measured against the reproduced baseline with statistical significance (paired t-test / Wilcoxon).</a:t>
+            </a:r>
+          </a:p>
+        </p:txBody>
+      </p:sp>
     </p:spTree>
     <p:extLst>
       <p:ext uri="{BB962C8B-B14F-4D97-AF65-F5344CB8AC3E}">
-        <p14:creationId xmlns:p14="http://schemas.microsoft.com/office/powerpoint/2010/main" val="28790724"/>
+        <p14:creationId xmlns:p14="http://schemas.microsoft.com/office/powerpoint/2010/main" val="3472489374"/>
       </p:ext>
     </p:extLst>
   </p:cSld>
@@ -5453,7 +5447,7 @@
           <p:cNvPr id="2" name="Title 1">
             <a:extLst>
               <a:ext uri="{FF2B5EF4-FFF2-40B4-BE49-F238E27FC236}">
-                <a16:creationId xmlns:a16="http://schemas.microsoft.com/office/drawing/2014/main" id="{E1601173-DB9D-2A55-1AC2-0B9A8596196D}"/>
+                <a16:creationId xmlns:a16="http://schemas.microsoft.com/office/drawing/2014/main" id="{E9AA656B-0821-0969-8445-5D6D4A103478}"/>
               </a:ext>
             </a:extLst>
           </p:cNvPr>
@@ -5475,11 +5469,10 @@
                 <a:solidFill>
                   <a:srgbClr val="002060"/>
                 </a:solidFill>
-                <a:latin typeface="Aptos" panose="020B0004020202020204" pitchFamily="34" charset="0"/>
               </a:rPr>
-              <a:t>Contributions</a:t>
-            </a:r>
-            <a:endParaRPr lang="en-US" b="1" dirty="0">
+              <a:t>Enhancements, Improvements &amp; Next-Review Work</a:t>
+            </a:r>
+            <a:endParaRPr lang="en-US" dirty="0">
               <a:solidFill>
                 <a:srgbClr val="002060"/>
               </a:solidFill>
@@ -5492,7 +5485,7 @@
           <p:cNvPr id="3" name="Content Placeholder 2">
             <a:extLst>
               <a:ext uri="{FF2B5EF4-FFF2-40B4-BE49-F238E27FC236}">
-                <a16:creationId xmlns:a16="http://schemas.microsoft.com/office/drawing/2014/main" id="{05E775B2-4CCF-E3CC-67EB-BAFDAAE3AD8B}"/>
+                <a16:creationId xmlns:a16="http://schemas.microsoft.com/office/drawing/2014/main" id="{7EC7D505-03EF-17A6-20CD-8D127B1AE7E3}"/>
               </a:ext>
             </a:extLst>
           </p:cNvPr>
@@ -5509,26 +5502,20 @@
           <a:lstStyle/>
           <a:p>
             <a:r>
-              <a:rPr lang="en-US" dirty="0"/>
-              <a:t>1) Execution-guided self-correction — detect SQL that fails to execute and repair it automatically (prototype already built; formalised and measured in Month 3).</a:t>
-            </a:r>
-          </a:p>
-          <a:p>
-            <a:r>
-              <a:rPr lang="en-US" dirty="0"/>
-              <a:t>2) Confidence-aware abstention (novel) — generate multiple candidates, measure their agreement, and abstain with a clarifying question when confidence is low; reported as an accuracy-vs-coverage curve. Existing systems answer with uniform confidence and never report this.</a:t>
-            </a:r>
-          </a:p>
-          <a:p>
-            <a:r>
-              <a:rPr lang="en-US" dirty="0"/>
-              <a:t>3) Benchmark-to-reality gap — evaluate on a custom academic schema alongside Spider to quantify and narrow the drop published models show on real databases.</a:t>
-            </a:r>
-          </a:p>
-          <a:p>
-            <a:r>
-              <a:rPr lang="en-US" dirty="0"/>
-              <a:t>Each enhancement is measured against the reproduced baseline with statistical significance (paired t-test / Wilcoxon).</a:t>
+              <a:rPr lang="en-US" b="1" dirty="0"/>
+              <a:t>Reproducibility documentation: a 10-page Code Reproducibility Report accompanies this review (scope, environment, executed runs, documented deviations, metrics, artefact index).</a:t>
+            </a:r>
+          </a:p>
+          <a:p>
+            <a:r>
+              <a:rPr lang="en-US" b="1" dirty="0"/>
+              <a:t>Improvement to close the reproduction gap: adopt the full CodeS database prompt (schema filter + BM25 value retriever + metadata) to move EX from 64.8% toward the reported 77.9%.</a:t>
+            </a:r>
+          </a:p>
+          <a:p>
+            <a:r>
+              <a:rPr lang="en-US" b="1" dirty="0"/>
+              <a:t>Next-review work: complete the full 1034-example Spider-dev run and log three runs; finalise EX vs the 77.9% target; Week-7 schema-filter ablation; begin the enhancement implementation (self-correction → confidence-aware abstention).</a:t>
             </a:r>
           </a:p>
         </p:txBody>
@@ -5536,7 +5523,7 @@
     </p:spTree>
     <p:extLst>
       <p:ext uri="{BB962C8B-B14F-4D97-AF65-F5344CB8AC3E}">
-        <p14:creationId xmlns:p14="http://schemas.microsoft.com/office/powerpoint/2010/main" val="3472489374"/>
+        <p14:creationId xmlns:p14="http://schemas.microsoft.com/office/powerpoint/2010/main" val="62151320"/>
       </p:ext>
     </p:extLst>
   </p:cSld>
@@ -5568,7 +5555,7 @@
           <p:cNvPr id="2" name="Title 1">
             <a:extLst>
               <a:ext uri="{FF2B5EF4-FFF2-40B4-BE49-F238E27FC236}">
-                <a16:creationId xmlns:a16="http://schemas.microsoft.com/office/drawing/2014/main" id="{E9AA656B-0821-0969-8445-5D6D4A103478}"/>
+                <a16:creationId xmlns:a16="http://schemas.microsoft.com/office/drawing/2014/main" id="{6CC3C1D4-A931-668D-A188-5C11E68A1302}"/>
               </a:ext>
             </a:extLst>
           </p:cNvPr>
@@ -5591,13 +5578,8 @@
                   <a:srgbClr val="002060"/>
                 </a:solidFill>
               </a:rPr>
-              <a:t>Enhancements, Improvements &amp; Next-Review Work</a:t>
-            </a:r>
-            <a:endParaRPr lang="en-US" dirty="0">
-              <a:solidFill>
-                <a:srgbClr val="002060"/>
-              </a:solidFill>
-            </a:endParaRPr>
+              <a:t>References</a:t>
+            </a:r>
           </a:p>
         </p:txBody>
       </p:sp>
@@ -5606,7 +5588,7 @@
           <p:cNvPr id="3" name="Content Placeholder 2">
             <a:extLst>
               <a:ext uri="{FF2B5EF4-FFF2-40B4-BE49-F238E27FC236}">
-                <a16:creationId xmlns:a16="http://schemas.microsoft.com/office/drawing/2014/main" id="{7EC7D505-03EF-17A6-20CD-8D127B1AE7E3}"/>
+                <a16:creationId xmlns:a16="http://schemas.microsoft.com/office/drawing/2014/main" id="{E4A35C1D-7495-EB2D-9FA3-079F416634F4}"/>
               </a:ext>
             </a:extLst>
           </p:cNvPr>
@@ -5623,20 +5605,38 @@
           <a:lstStyle/>
           <a:p>
             <a:r>
-              <a:rPr lang="en-US" b="1" dirty="0"/>
-              <a:t>Reproducibility documentation: a 10-page Code Reproducibility Report accompanies this review (scope, environment, executed runs, documented deviations, metrics, artefact index).</a:t>
-            </a:r>
-          </a:p>
-          <a:p>
-            <a:r>
-              <a:rPr lang="en-US" b="1" dirty="0"/>
-              <a:t>Improvement to close the reproduction gap: adopt the full CodeS database prompt (schema filter + BM25 value retriever + metadata) to move EX from 73.3% toward the reported 77.9%.</a:t>
-            </a:r>
-          </a:p>
-          <a:p>
-            <a:r>
-              <a:rPr lang="en-US" b="1" dirty="0"/>
-              <a:t>Next-review work: complete the full 1034-example Spider-dev run and log three runs; finalise EX vs the 77.9% target; Week-7 schema-filter ablation; begin the enhancement implementation (self-correction → confidence-aware abstention).</a:t>
+              <a:rPr lang="en-US" dirty="0"/>
+              <a:t>Li, H., et al. (2024). CodeS: Towards Building Open-source Language Models for Text-to-SQL. SIGMOD. arXiv:2402.16347</a:t>
+            </a:r>
+          </a:p>
+          <a:p>
+            <a:r>
+              <a:rPr lang="en-US" dirty="0"/>
+              <a:t>Li, H., et al. (2023). RESDSQL: Decoupling Schema Linking and Skeleton Parsing for Text-to-SQL. AAAI. arXiv:2302.05965</a:t>
+            </a:r>
+          </a:p>
+          <a:p>
+            <a:r>
+              <a:rPr lang="en-US" dirty="0"/>
+              <a:t>Pourreza, M., &amp; Rafiei, D. (2023). DIN-SQL: Decomposed In-Context Learning of Text-to-SQL with Self-Correction. NeurIPS. arXiv:2304.11015</a:t>
+            </a:r>
+          </a:p>
+          <a:p>
+            <a:r>
+              <a:rPr lang="en-US" dirty="0"/>
+              <a:t>Dibia, V. (2023). LIDA: Automatic Generation of Grammar-Agnostic Visualizations using LLMs. ACL. arXiv:2303.02927</a:t>
+            </a:r>
+          </a:p>
+          <a:p>
+            <a:r>
+              <a:rPr lang="en-US" dirty="0"/>
+              <a:t>Yu, T., et al. (2018). Spider: A Large-Scale Dataset for Complex and Cross-Domain Text-to-SQL. EMNLP. arXiv:1809.08887</a:t>
+            </a:r>
+          </a:p>
+          <a:p>
+            <a:r>
+              <a:rPr lang="en-US" dirty="0"/>
+              <a:t>Li, R., et al. (2023). StarCoder: may the source be with you! arXiv:2305.06161</a:t>
             </a:r>
           </a:p>
         </p:txBody>
@@ -5644,7 +5644,7 @@
     </p:spTree>
     <p:extLst>
       <p:ext uri="{BB962C8B-B14F-4D97-AF65-F5344CB8AC3E}">
-        <p14:creationId xmlns:p14="http://schemas.microsoft.com/office/powerpoint/2010/main" val="62151320"/>
+        <p14:creationId xmlns:p14="http://schemas.microsoft.com/office/powerpoint/2010/main" val="2237049153"/>
       </p:ext>
     </p:extLst>
   </p:cSld>

</xml_diff>

<commit_message>
Tier-2 PASSING: faithful CodeS prompt reproduces Spider dev EX 71.7% (within ±10%)
Full 1034-example Spider dev run with the authors' full database prompt (schema +
representative values + question-matched values, T4/Colab): EX = 71.7% (741/1034),
within the SOP ±10% tolerance of the reported 77.9% (~8% relative). Up from 64.8%
with the schema-only prompt — isolating the value retriever as the decisive part.

- reproduction_log: T2-002 logged
- deck slide 6: results table + text updated to 71.7% / within tolerance
- reproducibility report: T2-001 vs T2-002 comparison, residual-gap causes, within-tolerance conclusion
- DELIVERABLES: Month-2 reproduction rows updated

Co-Authored-By: Claude Opus 4.8 <noreply@anthropic.com>
</commit_message>
<xml_diff>
--- a/docs/reviews/Review2_QueryGenie.pptx
+++ b/docs/reviews/Review2_QueryGenie.pptx
@@ -5139,7 +5139,7 @@
                     <a:lstStyle/>
                     <a:p>
                       <a:r>
-                        <a:t>codes-1b-spider</a:t>
+                        <a:t>codes-1b-spider (full prompt)</a:t>
                       </a:r>
                     </a:p>
                   </a:txBody>
@@ -5163,7 +5163,7 @@
                     <a:lstStyle/>
                     <a:p>
                       <a:r>
-                        <a:t>64.8% (full 1034 dev)</a:t>
+                        <a:t>71.7% (faithful, full 1034)</a:t>
                       </a:r>
                     </a:p>
                   </a:txBody>
@@ -5175,7 +5175,7 @@
                     <a:lstStyle/>
                     <a:p>
                       <a:r>
-                        <a:t>Outside ±10%; documented cause</a:t>
+                        <a:t>Within ±10% tolerance ✓</a:t>
                       </a:r>
                     </a:p>
                   </a:txBody>
@@ -5242,7 +5242,7 @@
                     <a:lstStyle/>
                     <a:p>
                       <a:r>
-                        <a:t>Gap −13.1 pts (prompt fidelity)</a:t>
+                        <a:t>Reproduced (−6.2 pts, ~8%)</a:t>
                       </a:r>
                     </a:p>
                   </a:txBody>
@@ -5292,7 +5292,7 @@
             </a:pPr>
             <a:r>
               <a:rPr lang="en-US" dirty="0"/>
-              <a:t>Full Spider-dev EX = 64.8% (670/1034; 92.9% executed) vs the paper's 77.9%. The gap is a documented deviation: our prompt is schema+FK only, not the authors' full database prompt (schema filter + BM25 value retriever + metadata) that the SFT model expects. Adopting the full prompt is the planned improvement.</a:t>
+              <a:t>Full Spider-dev EX = 71.7% with the faithful CodeS prompt (schema + representative values + question-matched values) — within the ±10% tolerance of the paper's 77.9%. This recovered +6.9 points over the schema-only prompt (64.8%), confirming the value retriever was the gap. Residual ~8% is our distinct-scan value match vs their Lucene pipeline and EX-by-result-set vs the official test-suite.</a:t>
             </a:r>
           </a:p>
         </p:txBody>
@@ -5509,7 +5509,7 @@
           <a:p>
             <a:r>
               <a:rPr lang="en-US" b="1" dirty="0"/>
-              <a:t>Improvement to close the reproduction gap: adopt the full CodeS database prompt (schema filter + BM25 value retriever + metadata) to move EX from 64.8% toward the reported 77.9%.</a:t>
+              <a:t>Result of that improvement: adopting the full CodeS prompt (schema filter + value retriever + metadata) raised EX from 64.8% to 71.7% — within ±10% of the reported 77.9%.</a:t>
             </a:r>
           </a:p>
           <a:p>

</xml_diff>

<commit_message>
Move annotated CodeS paper to docs/
Co-Authored-By: Claude Opus 4.8 <noreply@anthropic.com>
</commit_message>
<xml_diff>
--- a/docs/reviews/Review2_QueryGenie.pptx
+++ b/docs/reviews/Review2_QueryGenie.pptx
@@ -8,13 +8,13 @@
     <p:sldId id="264" r:id="rId2"/>
     <p:sldId id="265" r:id="rId3"/>
     <p:sldId id="270" r:id="rId4"/>
-    <p:sldId id="268" r:id="rId8"/>
-    <p:sldId id="267" r:id="rId7"/>
-    <p:sldId id="266" r:id="rId5"/>
-    <p:sldId id="272" r:id="rId9"/>
-    <p:sldId id="271" r:id="rId10"/>
-    <p:sldId id="273" r:id="rId11"/>
-    <p:sldId id="274" r:id="rId12"/>
+    <p:sldId id="268" r:id="rId5"/>
+    <p:sldId id="267" r:id="rId6"/>
+    <p:sldId id="266" r:id="rId7"/>
+    <p:sldId id="272" r:id="rId8"/>
+    <p:sldId id="271" r:id="rId9"/>
+    <p:sldId id="273" r:id="rId10"/>
+    <p:sldId id="274" r:id="rId11"/>
   </p:sldIdLst>
   <p:sldSz cx="12192000" cy="6858000"/>
   <p:notesSz cx="6858000" cy="9144000"/>
@@ -268,7 +268,7 @@
           <a:p>
             <a:fld id="{3EC861E2-95D1-6345-9736-0F1D842AE3C6}" type="datetimeFigureOut">
               <a:rPr lang="en-US" smtClean="0"/>
-              <a:t>8/3/26</a:t>
+              <a:t>8/29/26</a:t>
             </a:fld>
             <a:endParaRPr lang="en-US"/>
           </a:p>
@@ -466,7 +466,7 @@
           <a:p>
             <a:fld id="{3EC861E2-95D1-6345-9736-0F1D842AE3C6}" type="datetimeFigureOut">
               <a:rPr lang="en-US" smtClean="0"/>
-              <a:t>8/3/26</a:t>
+              <a:t>8/29/26</a:t>
             </a:fld>
             <a:endParaRPr lang="en-US"/>
           </a:p>
@@ -674,7 +674,7 @@
           <a:p>
             <a:fld id="{3EC861E2-95D1-6345-9736-0F1D842AE3C6}" type="datetimeFigureOut">
               <a:rPr lang="en-US" smtClean="0"/>
-              <a:t>8/3/26</a:t>
+              <a:t>8/29/26</a:t>
             </a:fld>
             <a:endParaRPr lang="en-US"/>
           </a:p>
@@ -872,7 +872,7 @@
           <a:p>
             <a:fld id="{3EC861E2-95D1-6345-9736-0F1D842AE3C6}" type="datetimeFigureOut">
               <a:rPr lang="en-US" smtClean="0"/>
-              <a:t>8/3/26</a:t>
+              <a:t>8/29/26</a:t>
             </a:fld>
             <a:endParaRPr lang="en-US"/>
           </a:p>
@@ -1147,7 +1147,7 @@
           <a:p>
             <a:fld id="{3EC861E2-95D1-6345-9736-0F1D842AE3C6}" type="datetimeFigureOut">
               <a:rPr lang="en-US" smtClean="0"/>
-              <a:t>8/3/26</a:t>
+              <a:t>8/29/26</a:t>
             </a:fld>
             <a:endParaRPr lang="en-US"/>
           </a:p>
@@ -1412,7 +1412,7 @@
           <a:p>
             <a:fld id="{3EC861E2-95D1-6345-9736-0F1D842AE3C6}" type="datetimeFigureOut">
               <a:rPr lang="en-US" smtClean="0"/>
-              <a:t>8/3/26</a:t>
+              <a:t>8/29/26</a:t>
             </a:fld>
             <a:endParaRPr lang="en-US"/>
           </a:p>
@@ -1824,7 +1824,7 @@
           <a:p>
             <a:fld id="{3EC861E2-95D1-6345-9736-0F1D842AE3C6}" type="datetimeFigureOut">
               <a:rPr lang="en-US" smtClean="0"/>
-              <a:t>8/3/26</a:t>
+              <a:t>8/29/26</a:t>
             </a:fld>
             <a:endParaRPr lang="en-US"/>
           </a:p>
@@ -1965,7 +1965,7 @@
           <a:p>
             <a:fld id="{3EC861E2-95D1-6345-9736-0F1D842AE3C6}" type="datetimeFigureOut">
               <a:rPr lang="en-US" smtClean="0"/>
-              <a:t>8/3/26</a:t>
+              <a:t>8/29/26</a:t>
             </a:fld>
             <a:endParaRPr lang="en-US"/>
           </a:p>
@@ -2078,7 +2078,7 @@
           <a:p>
             <a:fld id="{3EC861E2-95D1-6345-9736-0F1D842AE3C6}" type="datetimeFigureOut">
               <a:rPr lang="en-US" smtClean="0"/>
-              <a:t>8/3/26</a:t>
+              <a:t>8/29/26</a:t>
             </a:fld>
             <a:endParaRPr lang="en-US"/>
           </a:p>
@@ -2389,7 +2389,7 @@
           <a:p>
             <a:fld id="{3EC861E2-95D1-6345-9736-0F1D842AE3C6}" type="datetimeFigureOut">
               <a:rPr lang="en-US" smtClean="0"/>
-              <a:t>8/3/26</a:t>
+              <a:t>8/29/26</a:t>
             </a:fld>
             <a:endParaRPr lang="en-US"/>
           </a:p>
@@ -2677,7 +2677,7 @@
           <a:p>
             <a:fld id="{3EC861E2-95D1-6345-9736-0F1D842AE3C6}" type="datetimeFigureOut">
               <a:rPr lang="en-US" smtClean="0"/>
-              <a:t>8/3/26</a:t>
+              <a:t>8/29/26</a:t>
             </a:fld>
             <a:endParaRPr lang="en-US"/>
           </a:p>
@@ -2937,7 +2937,7 @@
           <a:p>
             <a:fld id="{3EC861E2-95D1-6345-9736-0F1D842AE3C6}" type="datetimeFigureOut">
               <a:rPr lang="en-US" smtClean="0"/>
-              <a:t>8/3/26</a:t>
+              <a:t>8/29/26</a:t>
             </a:fld>
             <a:endParaRPr lang="en-US"/>
           </a:p>
@@ -4440,7 +4440,7 @@
           <a:p>
             <a:r>
               <a:rPr lang="en-US" b="1" dirty="0"/>
-              <a:t>Reproducibility documentation (10 pages)</a:t>
+              <a:t>Reproducibility documentation</a:t>
             </a:r>
           </a:p>
           <a:p>
@@ -4536,9 +4536,16 @@
             <p:ph idx="1"/>
           </p:nvPr>
         </p:nvSpPr>
-        <p:spPr/>
-        <p:txBody>
-          <a:bodyPr wrap="square"/>
+        <p:spPr>
+          <a:xfrm>
+            <a:off x="755073" y="1526464"/>
+            <a:ext cx="10515600" cy="4351338"/>
+          </a:xfrm>
+        </p:spPr>
+        <p:txBody>
+          <a:bodyPr wrap="square">
+            <a:normAutofit fontScale="92500" lnSpcReduction="20000"/>
+          </a:bodyPr>
           <a:lstStyle/>
           <a:p>
             <a:r>
@@ -4649,10 +4656,7 @@
           <a:bodyPr/>
           <a:lstStyle/>
           <a:p>
-            <a:r>
-              <a:rPr lang="en-US" dirty="0"/>
-              <a:t/>
-            </a:r>
+            <a:endParaRPr/>
           </a:p>
         </p:txBody>
       </p:sp>
@@ -4764,14 +4768,29 @@
             <p:ph idx="1"/>
           </p:nvPr>
         </p:nvSpPr>
-        <p:spPr/>
-        <p:txBody>
-          <a:bodyPr wrap="square"/>
+        <p:spPr>
+          <a:xfrm>
+            <a:off x="838200" y="1690689"/>
+            <a:ext cx="10515600" cy="4351338"/>
+          </a:xfrm>
+        </p:spPr>
+        <p:txBody>
+          <a:bodyPr wrap="square">
+            <a:normAutofit lnSpcReduction="10000"/>
+          </a:bodyPr>
           <a:lstStyle/>
           <a:p>
             <a:r>
               <a:rPr lang="en-US" dirty="0"/>
-              <a:t>Repository: github.com/jayakanthh/QueryGenie  (private; project supervisor and both team members added as collaborators — both commit under their own accounts).</a:t>
+              <a:t>Repository: github.com/jayakanthh/</a:t>
+            </a:r>
+            <a:r>
+              <a:rPr lang="en-US" dirty="0" err="1"/>
+              <a:t>QueryGenie</a:t>
+            </a:r>
+            <a:r>
+              <a:rPr lang="en-US" dirty="0"/>
+              <a:t>  (project supervisor and both team members added as collaborators ).</a:t>
             </a:r>
           </a:p>
           <a:p>
@@ -4783,7 +4802,7 @@
           <a:p>
             <a:r>
               <a:rPr lang="en-US" dirty="0"/>
-              <a:t>Run locally:  pip install -r requirements.txt  →  python src/app.py.  The dataset and model weights are fetched from approved sources (Hugging Face); large artefacts are git-ignored and regenerable.</a:t>
+              <a:t>Run locally:  pip install -r requirements.txt  →  python src/app.py.  The dataset and model weights are fetched from approved sources (Hugging Face); large artifacts are git-ignored and regenerable.</a:t>
             </a:r>
           </a:p>
         </p:txBody>
@@ -4867,14 +4886,14 @@
           <p:nvPr>
             <p:extLst>
               <p:ext uri="{D42A27DB-BD31-4B8C-83A1-F6EECF244321}">
-                <p14:modId xmlns:p14="http://schemas.microsoft.com/office/powerpoint/2010/main" val="1022050429"/>
+                <p14:modId xmlns:p14="http://schemas.microsoft.com/office/powerpoint/2010/main" val="12244317"/>
               </p:ext>
             </p:extLst>
           </p:nvPr>
         </p:nvGraphicFramePr>
         <p:xfrm>
-          <a:off x="614275" y="2501900"/>
-          <a:ext cx="11193345" cy="1854200"/>
+          <a:off x="614275" y="3107541"/>
+          <a:ext cx="11193345" cy="2661920"/>
         </p:xfrm>
         <a:graphic>
           <a:graphicData uri="http://schemas.openxmlformats.org/drawingml/2006/table">
@@ -5242,6 +5261,7 @@
                     <a:lstStyle/>
                     <a:p>
                       <a:r>
+                        <a:rPr dirty="0"/>
                         <a:t>Reproduced (−6.2 pts, ~8%)</a:t>
                       </a:r>
                     </a:p>
@@ -5272,8 +5292,8 @@
         </p:nvSpPr>
         <p:spPr>
           <a:xfrm>
-            <a:off x="758537" y="1726962"/>
-            <a:ext cx="9404754" cy="369332"/>
+            <a:off x="1065538" y="1357631"/>
+            <a:ext cx="9537141" cy="1477328"/>
           </a:xfrm>
           <a:prstGeom prst="rect">
             <a:avLst/>
@@ -5281,7 +5301,7 @@
           <a:noFill/>
         </p:spPr>
         <p:txBody>
-          <a:bodyPr wrap="none" rtlCol="0">
+          <a:bodyPr wrap="square" rtlCol="0">
             <a:spAutoFit/>
           </a:bodyPr>
           <a:lstStyle/>
@@ -5292,7 +5312,15 @@
             </a:pPr>
             <a:r>
               <a:rPr lang="en-US" dirty="0"/>
-              <a:t>Full Spider-dev EX = 71.7% with the faithful CodeS prompt (schema + representative values + question-matched values) — within the ±10% tolerance of the paper's 77.9%. This recovered +6.9 points over the schema-only prompt (64.8%), confirming the value retriever was the gap. Residual ~8% is our distinct-scan value match vs their Lucene pipeline and EX-by-result-set vs the official test-suite.</a:t>
+              <a:t>Full Spider-dev EX = 71.7% with the faithful </a:t>
+            </a:r>
+            <a:r>
+              <a:rPr lang="en-US" dirty="0" err="1"/>
+              <a:t>CodeS</a:t>
+            </a:r>
+            <a:r>
+              <a:rPr lang="en-US" dirty="0"/>
+              <a:t> prompt (schema + representative values + question-matched values) — within the ±10% tolerance of the paper's 77.9%. This recovered +6.9 points over the schema-only prompt (64.8%), confirming the value retriever was the gap. Residual ~8% is our distinct-scan value match vs their Lucene pipeline and EX-by-result-set vs the official test-suite.</a:t>
             </a:r>
           </a:p>
         </p:txBody>
@@ -5382,9 +5410,16 @@
             <p:ph idx="1"/>
           </p:nvPr>
         </p:nvSpPr>
-        <p:spPr/>
-        <p:txBody>
-          <a:bodyPr wrap="square"/>
+        <p:spPr>
+          <a:xfrm>
+            <a:off x="838200" y="1813750"/>
+            <a:ext cx="10515600" cy="4351338"/>
+          </a:xfrm>
+        </p:spPr>
+        <p:txBody>
+          <a:bodyPr wrap="square">
+            <a:normAutofit fontScale="92500" lnSpcReduction="20000"/>
+          </a:bodyPr>
           <a:lstStyle/>
           <a:p>
             <a:r>
@@ -5496,9 +5531,16 @@
             <p:ph idx="1"/>
           </p:nvPr>
         </p:nvSpPr>
-        <p:spPr/>
-        <p:txBody>
-          <a:bodyPr wrap="square"/>
+        <p:spPr>
+          <a:xfrm>
+            <a:off x="838200" y="1690689"/>
+            <a:ext cx="10515600" cy="4351338"/>
+          </a:xfrm>
+        </p:spPr>
+        <p:txBody>
+          <a:bodyPr wrap="square">
+            <a:normAutofit fontScale="92500"/>
+          </a:bodyPr>
           <a:lstStyle/>
           <a:p>
             <a:r>
@@ -5599,9 +5641,16 @@
             <p:ph idx="1"/>
           </p:nvPr>
         </p:nvSpPr>
-        <p:spPr/>
-        <p:txBody>
-          <a:bodyPr wrap="square"/>
+        <p:spPr>
+          <a:xfrm>
+            <a:off x="838200" y="1813750"/>
+            <a:ext cx="10515600" cy="4351338"/>
+          </a:xfrm>
+        </p:spPr>
+        <p:txBody>
+          <a:bodyPr wrap="square">
+            <a:normAutofit fontScale="85000" lnSpcReduction="10000"/>
+          </a:bodyPr>
           <a:lstStyle/>
           <a:p>
             <a:r>

</xml_diff>

<commit_message>
Week 5/6: weekly report, filled Reproduction_Log.xlsx, comparison table vs paper
Co-Authored-By: Claude Opus 5 <noreply@anthropic.com>
</commit_message>
<xml_diff>
--- a/docs/reviews/Review2_QueryGenie.pptx
+++ b/docs/reviews/Review2_QueryGenie.pptx
@@ -268,7 +268,7 @@
           <a:p>
             <a:fld id="{3EC861E2-95D1-6345-9736-0F1D842AE3C6}" type="datetimeFigureOut">
               <a:rPr lang="en-US" smtClean="0"/>
-              <a:t>8/29/26</a:t>
+              <a:t>9/8/26</a:t>
             </a:fld>
             <a:endParaRPr lang="en-US"/>
           </a:p>
@@ -466,7 +466,7 @@
           <a:p>
             <a:fld id="{3EC861E2-95D1-6345-9736-0F1D842AE3C6}" type="datetimeFigureOut">
               <a:rPr lang="en-US" smtClean="0"/>
-              <a:t>8/29/26</a:t>
+              <a:t>9/8/26</a:t>
             </a:fld>
             <a:endParaRPr lang="en-US"/>
           </a:p>
@@ -674,7 +674,7 @@
           <a:p>
             <a:fld id="{3EC861E2-95D1-6345-9736-0F1D842AE3C6}" type="datetimeFigureOut">
               <a:rPr lang="en-US" smtClean="0"/>
-              <a:t>8/29/26</a:t>
+              <a:t>9/8/26</a:t>
             </a:fld>
             <a:endParaRPr lang="en-US"/>
           </a:p>
@@ -872,7 +872,7 @@
           <a:p>
             <a:fld id="{3EC861E2-95D1-6345-9736-0F1D842AE3C6}" type="datetimeFigureOut">
               <a:rPr lang="en-US" smtClean="0"/>
-              <a:t>8/29/26</a:t>
+              <a:t>9/8/26</a:t>
             </a:fld>
             <a:endParaRPr lang="en-US"/>
           </a:p>
@@ -1147,7 +1147,7 @@
           <a:p>
             <a:fld id="{3EC861E2-95D1-6345-9736-0F1D842AE3C6}" type="datetimeFigureOut">
               <a:rPr lang="en-US" smtClean="0"/>
-              <a:t>8/29/26</a:t>
+              <a:t>9/8/26</a:t>
             </a:fld>
             <a:endParaRPr lang="en-US"/>
           </a:p>
@@ -1412,7 +1412,7 @@
           <a:p>
             <a:fld id="{3EC861E2-95D1-6345-9736-0F1D842AE3C6}" type="datetimeFigureOut">
               <a:rPr lang="en-US" smtClean="0"/>
-              <a:t>8/29/26</a:t>
+              <a:t>9/8/26</a:t>
             </a:fld>
             <a:endParaRPr lang="en-US"/>
           </a:p>
@@ -1824,7 +1824,7 @@
           <a:p>
             <a:fld id="{3EC861E2-95D1-6345-9736-0F1D842AE3C6}" type="datetimeFigureOut">
               <a:rPr lang="en-US" smtClean="0"/>
-              <a:t>8/29/26</a:t>
+              <a:t>9/8/26</a:t>
             </a:fld>
             <a:endParaRPr lang="en-US"/>
           </a:p>
@@ -1965,7 +1965,7 @@
           <a:p>
             <a:fld id="{3EC861E2-95D1-6345-9736-0F1D842AE3C6}" type="datetimeFigureOut">
               <a:rPr lang="en-US" smtClean="0"/>
-              <a:t>8/29/26</a:t>
+              <a:t>9/8/26</a:t>
             </a:fld>
             <a:endParaRPr lang="en-US"/>
           </a:p>
@@ -2078,7 +2078,7 @@
           <a:p>
             <a:fld id="{3EC861E2-95D1-6345-9736-0F1D842AE3C6}" type="datetimeFigureOut">
               <a:rPr lang="en-US" smtClean="0"/>
-              <a:t>8/29/26</a:t>
+              <a:t>9/8/26</a:t>
             </a:fld>
             <a:endParaRPr lang="en-US"/>
           </a:p>
@@ -2389,7 +2389,7 @@
           <a:p>
             <a:fld id="{3EC861E2-95D1-6345-9736-0F1D842AE3C6}" type="datetimeFigureOut">
               <a:rPr lang="en-US" smtClean="0"/>
-              <a:t>8/29/26</a:t>
+              <a:t>9/8/26</a:t>
             </a:fld>
             <a:endParaRPr lang="en-US"/>
           </a:p>
@@ -2677,7 +2677,7 @@
           <a:p>
             <a:fld id="{3EC861E2-95D1-6345-9736-0F1D842AE3C6}" type="datetimeFigureOut">
               <a:rPr lang="en-US" smtClean="0"/>
-              <a:t>8/29/26</a:t>
+              <a:t>9/8/26</a:t>
             </a:fld>
             <a:endParaRPr lang="en-US"/>
           </a:p>
@@ -2937,7 +2937,7 @@
           <a:p>
             <a:fld id="{3EC861E2-95D1-6345-9736-0F1D842AE3C6}" type="datetimeFigureOut">
               <a:rPr lang="en-US" smtClean="0"/>
-              <a:t>8/29/26</a:t>
+              <a:t>9/8/26</a:t>
             </a:fld>
             <a:endParaRPr lang="en-US"/>
           </a:p>
@@ -3429,7 +3429,7 @@
             <a:pPr algn="r"/>
             <a:r>
               <a:rPr lang="en-US" dirty="0"/>
-              <a:t>Project Review II   ·   29 August 2026</a:t>
+              <a:t>Project Review II   </a:t>
             </a:r>
           </a:p>
         </p:txBody>

</xml_diff>

<commit_message>
Team: list M Praneeth Reddy on all records; Boddupally spelling everywhere
Weekly reports 1-12 (ID line), Week-1 abstract and deck, Week-3 worksheet,
Review-II deck, reproducibility report v1. Abstract kept to one page
(removed a blank line before the signature); proposal verified still one
page in Word.

Co-Authored-By: Claude Opus 5.5 <noreply@anthropic.com>
</commit_message>
<xml_diff>
--- a/docs/reviews/Review2_QueryGenie.pptx
+++ b/docs/reviews/Review2_QueryGenie.pptx
@@ -3422,7 +3422,14 @@
             <a:pPr algn="r"/>
             <a:r>
               <a:rPr lang="en-US" dirty="0"/>
-              <a:t>2320090009 : Bodupally Narendar</a:t>
+              <a:t>2320090009 : Boddupally Narendar</a:t>
+            </a:r>
+          </a:p>
+          <a:p>
+            <a:pPr algn="r"/>
+            <a:r>
+              <a:rPr lang="en-US" dirty="0"/>
+              <a:t>2320090018 : M Praneeth Reddy</a:t>
             </a:r>
           </a:p>
           <a:p>

</xml_diff>